<commit_message>
docs: add live URLs
</commit_message>
<xml_diff>
--- a/presentation/cinematch_milestone5.pptx
+++ b/presentation/cinematch_milestone5.pptx
@@ -3036,7 +3036,7 @@
                 <a:ea typeface="Calibri" pitchFamily="34" charset="-122"/>
                 <a:cs typeface="Calibri" pitchFamily="34" charset="-120"/>
               </a:rPr>
-              <a:t>cinematch-[hash].vercel.app</a:t>
+              <a:t>final-deployment-data433.vercel.app</a:t>
             </a:r>
             <a:endParaRPr lang="en-US" sz="1800" dirty="0"/>
           </a:p>
@@ -3137,7 +3137,7 @@
                 <a:ea typeface="Calibri" pitchFamily="34" charset="-122"/>
                 <a:cs typeface="Calibri" pitchFamily="34" charset="-120"/>
               </a:rPr>
-              <a:t>cinematch-api.onrender.com/docs</a:t>
+              <a:t>finaldeploymentdata433.onrender.com/docs</a:t>
             </a:r>
             <a:endParaRPr lang="en-US" sz="1800" dirty="0"/>
           </a:p>
@@ -3940,7 +3940,7 @@
                 <a:ea typeface="Calibri" pitchFamily="34" charset="-122"/>
                 <a:cs typeface="Calibri" pitchFamily="34" charset="-120"/>
               </a:rPr>
-              <a:t>cinematch-[hash].vercel.app</a:t>
+              <a:t>final-deployment-data433.vercel.app</a:t>
             </a:r>
             <a:endParaRPr lang="en-US" sz="2600" dirty="0"/>
           </a:p>

</xml_diff>